<commit_message>
update in sequence diagrams
</commit_message>
<xml_diff>
--- a/Purrifier_final.pptx
+++ b/Purrifier_final.pptx
@@ -133,7 +133,57 @@
       </a:defRPr>
     </a:lvl9pPr>
   </p:defaultTextStyle>
+  <p:extLst>
+    <p:ext uri="{EFAFB233-063F-42B5-8137-9DF3F51BA10A}">
+      <p15:sldGuideLst xmlns:p15="http://schemas.microsoft.com/office/powerpoint/2012/main"/>
+    </p:ext>
+  </p:extLst>
 </p:presentation>
+</file>
+
+<file path=ppt/revisionInfo.xml><?xml version="1.0" encoding="utf-8"?>
+<p1510:revInfo xmlns:a="http://schemas.openxmlformats.org/drawingml/2006/main" xmlns:r="http://schemas.openxmlformats.org/officeDocument/2006/relationships" xmlns:p1510="http://schemas.microsoft.com/office/powerpoint/2015/10/main">
+  <p1510:revLst>
+    <p1510:client id="{D9EAE13F-1798-435A-84F6-4943723C7856}" v="1" dt="2025-04-21T19:32:35.153"/>
+  </p1510:revLst>
+</p1510:revInfo>
+</file>
+
+<file path=ppt/changesInfos/changesInfo1.xml><?xml version="1.0" encoding="utf-8"?>
+<pc:chgInfo xmlns:a="http://schemas.openxmlformats.org/drawingml/2006/main" xmlns:r="http://schemas.openxmlformats.org/officeDocument/2006/relationships" xmlns:ac="http://schemas.microsoft.com/office/drawing/2013/main/command" xmlns:pc="http://schemas.microsoft.com/office/powerpoint/2013/main/command">
+  <pc:docChgLst>
+    <pc:chgData name="Filip Brutovský" userId="c01b95bd-2f38-4bc3-ab7a-bd0d5879bbde" providerId="ADAL" clId="{D9EAE13F-1798-435A-84F6-4943723C7856}"/>
+    <pc:docChg chg="custSel modSld">
+      <pc:chgData name="Filip Brutovský" userId="c01b95bd-2f38-4bc3-ab7a-bd0d5879bbde" providerId="ADAL" clId="{D9EAE13F-1798-435A-84F6-4943723C7856}" dt="2025-04-21T19:32:43.095" v="3" actId="14100"/>
+      <pc:docMkLst>
+        <pc:docMk/>
+      </pc:docMkLst>
+      <pc:sldChg chg="addSp delSp modSp mod">
+        <pc:chgData name="Filip Brutovský" userId="c01b95bd-2f38-4bc3-ab7a-bd0d5879bbde" providerId="ADAL" clId="{D9EAE13F-1798-435A-84F6-4943723C7856}" dt="2025-04-21T19:32:43.095" v="3" actId="14100"/>
+        <pc:sldMkLst>
+          <pc:docMk/>
+          <pc:sldMk cId="2594665826" sldId="280"/>
+        </pc:sldMkLst>
+        <pc:picChg chg="del">
+          <ac:chgData name="Filip Brutovský" userId="c01b95bd-2f38-4bc3-ab7a-bd0d5879bbde" providerId="ADAL" clId="{D9EAE13F-1798-435A-84F6-4943723C7856}" dt="2025-04-21T19:32:19.212" v="0" actId="478"/>
+          <ac:picMkLst>
+            <pc:docMk/>
+            <pc:sldMk cId="2594665826" sldId="280"/>
+            <ac:picMk id="4" creationId="{87497822-4C4D-6D5E-899D-225778AE23FA}"/>
+          </ac:picMkLst>
+        </pc:picChg>
+        <pc:picChg chg="add mod">
+          <ac:chgData name="Filip Brutovský" userId="c01b95bd-2f38-4bc3-ab7a-bd0d5879bbde" providerId="ADAL" clId="{D9EAE13F-1798-435A-84F6-4943723C7856}" dt="2025-04-21T19:32:43.095" v="3" actId="14100"/>
+          <ac:picMkLst>
+            <pc:docMk/>
+            <pc:sldMk cId="2594665826" sldId="280"/>
+            <ac:picMk id="6" creationId="{D3D8E2D6-C61D-041F-3E17-505DC2E37559}"/>
+          </ac:picMkLst>
+        </pc:picChg>
+      </pc:sldChg>
+    </pc:docChg>
+  </pc:docChgLst>
+</pc:chgInfo>
 </file>
 
 <file path=ppt/slideLayouts/slideLayout1.xml><?xml version="1.0" encoding="utf-8"?>
@@ -283,7 +333,7 @@
           <a:p>
             <a:fld id="{76969C88-B244-455D-A017-012B25B1ACDD}" type="datetimeFigureOut">
               <a:rPr lang="en-US" smtClean="0"/>
-              <a:t>4/21/25</a:t>
+              <a:t>4/21/2025</a:t>
             </a:fld>
             <a:endParaRPr lang="en-US"/>
           </a:p>
@@ -481,7 +531,7 @@
           <a:p>
             <a:fld id="{76969C88-B244-455D-A017-012B25B1ACDD}" type="datetimeFigureOut">
               <a:rPr lang="en-US" smtClean="0"/>
-              <a:t>4/21/25</a:t>
+              <a:t>4/21/2025</a:t>
             </a:fld>
             <a:endParaRPr lang="en-US"/>
           </a:p>
@@ -689,7 +739,7 @@
           <a:p>
             <a:fld id="{76969C88-B244-455D-A017-012B25B1ACDD}" type="datetimeFigureOut">
               <a:rPr lang="en-US" smtClean="0"/>
-              <a:t>4/21/25</a:t>
+              <a:t>4/21/2025</a:t>
             </a:fld>
             <a:endParaRPr lang="en-US"/>
           </a:p>
@@ -888,7 +938,7 @@
           <a:p>
             <a:fld id="{76969C88-B244-455D-A017-012B25B1ACDD}" type="datetimeFigureOut">
               <a:rPr lang="en-US" smtClean="0"/>
-              <a:t>4/21/25</a:t>
+              <a:t>4/21/2025</a:t>
             </a:fld>
             <a:endParaRPr lang="en-US"/>
           </a:p>
@@ -1163,7 +1213,7 @@
           <a:p>
             <a:fld id="{76969C88-B244-455D-A017-012B25B1ACDD}" type="datetimeFigureOut">
               <a:rPr lang="en-US" smtClean="0"/>
-              <a:t>4/21/25</a:t>
+              <a:t>4/21/2025</a:t>
             </a:fld>
             <a:endParaRPr lang="en-US"/>
           </a:p>
@@ -1428,7 +1478,7 @@
           <a:p>
             <a:fld id="{76969C88-B244-455D-A017-012B25B1ACDD}" type="datetimeFigureOut">
               <a:rPr lang="en-US" smtClean="0"/>
-              <a:t>4/21/25</a:t>
+              <a:t>4/21/2025</a:t>
             </a:fld>
             <a:endParaRPr lang="en-US"/>
           </a:p>
@@ -1840,7 +1890,7 @@
           <a:p>
             <a:fld id="{76969C88-B244-455D-A017-012B25B1ACDD}" type="datetimeFigureOut">
               <a:rPr lang="en-US" smtClean="0"/>
-              <a:t>4/21/25</a:t>
+              <a:t>4/21/2025</a:t>
             </a:fld>
             <a:endParaRPr lang="en-US"/>
           </a:p>
@@ -1981,7 +2031,7 @@
           <a:p>
             <a:fld id="{76969C88-B244-455D-A017-012B25B1ACDD}" type="datetimeFigureOut">
               <a:rPr lang="en-US" smtClean="0"/>
-              <a:t>4/21/25</a:t>
+              <a:t>4/21/2025</a:t>
             </a:fld>
             <a:endParaRPr lang="en-US"/>
           </a:p>
@@ -2094,7 +2144,7 @@
           <a:p>
             <a:fld id="{76969C88-B244-455D-A017-012B25B1ACDD}" type="datetimeFigureOut">
               <a:rPr lang="en-US" smtClean="0"/>
-              <a:t>4/21/25</a:t>
+              <a:t>4/21/2025</a:t>
             </a:fld>
             <a:endParaRPr lang="en-US"/>
           </a:p>
@@ -2406,7 +2456,7 @@
           <a:p>
             <a:fld id="{76969C88-B244-455D-A017-012B25B1ACDD}" type="datetimeFigureOut">
               <a:rPr lang="en-US" smtClean="0"/>
-              <a:t>4/21/25</a:t>
+              <a:t>4/21/2025</a:t>
             </a:fld>
             <a:endParaRPr lang="en-US"/>
           </a:p>
@@ -2697,7 +2747,7 @@
           <a:p>
             <a:fld id="{76969C88-B244-455D-A017-012B25B1ACDD}" type="datetimeFigureOut">
               <a:rPr lang="en-US" smtClean="0"/>
-              <a:t>4/21/25</a:t>
+              <a:t>4/21/2025</a:t>
             </a:fld>
             <a:endParaRPr lang="en-US"/>
           </a:p>
@@ -3453,7 +3503,7 @@
             <a:fld id="{76969C88-B244-455D-A017-012B25B1ACDD}" type="datetimeFigureOut">
               <a:rPr lang="en-US" smtClean="0"/>
               <a:pPr/>
-              <a:t>4/21/25</a:t>
+              <a:t>4/21/2025</a:t>
             </a:fld>
             <a:endParaRPr lang="en-US"/>
           </a:p>
@@ -7396,10 +7446,10 @@
       </p:sp>
       <p:pic>
         <p:nvPicPr>
-          <p:cNvPr id="4" name="Obrázok 3" descr="Obrázok, na ktorom je text, snímka obrazovky, diagram, displej&#10;&#10;Obsah vygenerovaný umelou inteligenciou môže byť nesprávny.">
-            <a:extLst>
-              <a:ext uri="{FF2B5EF4-FFF2-40B4-BE49-F238E27FC236}">
-                <a16:creationId xmlns:a16="http://schemas.microsoft.com/office/drawing/2014/main" id="{87497822-4C4D-6D5E-899D-225778AE23FA}"/>
+          <p:cNvPr id="5" name="Obrázok 4" descr="Obrázok, na ktorom je text, diagram, snímka obrazovky, rovnobežný&#10;&#10;Obsah vygenerovaný umelou inteligenciou môže byť nesprávny.">
+            <a:extLst>
+              <a:ext uri="{FF2B5EF4-FFF2-40B4-BE49-F238E27FC236}">
+                <a16:creationId xmlns:a16="http://schemas.microsoft.com/office/drawing/2014/main" id="{D44C2F18-735A-7D10-8538-24B135328E36}"/>
               </a:ext>
             </a:extLst>
           </p:cNvPr>
@@ -7409,43 +7459,7 @@
           <p:nvPr/>
         </p:nvPicPr>
         <p:blipFill>
-          <a:blip r:embed="rId2">
-            <a:extLst>
-              <a:ext uri="{28A0092B-C50C-407E-A947-70E740481C1C}">
-                <a14:useLocalDpi xmlns:a14="http://schemas.microsoft.com/office/drawing/2010/main" val="0"/>
-              </a:ext>
-            </a:extLst>
-          </a:blip>
-          <a:stretch>
-            <a:fillRect/>
-          </a:stretch>
-        </p:blipFill>
-        <p:spPr>
-          <a:xfrm>
-            <a:off x="868997" y="1455303"/>
-            <a:ext cx="4708715" cy="4756254"/>
-          </a:xfrm>
-          <a:prstGeom prst="rect">
-            <a:avLst/>
-          </a:prstGeom>
-        </p:spPr>
-      </p:pic>
-      <p:pic>
-        <p:nvPicPr>
-          <p:cNvPr id="5" name="Obrázok 4" descr="Obrázok, na ktorom je text, diagram, snímka obrazovky, rovnobežný&#10;&#10;Obsah vygenerovaný umelou inteligenciou môže byť nesprávny.">
-            <a:extLst>
-              <a:ext uri="{FF2B5EF4-FFF2-40B4-BE49-F238E27FC236}">
-                <a16:creationId xmlns:a16="http://schemas.microsoft.com/office/drawing/2014/main" id="{D44C2F18-735A-7D10-8538-24B135328E36}"/>
-              </a:ext>
-            </a:extLst>
-          </p:cNvPr>
-          <p:cNvPicPr>
-            <a:picLocks noChangeAspect="1"/>
-          </p:cNvPicPr>
-          <p:nvPr/>
-        </p:nvPicPr>
-        <p:blipFill>
-          <a:blip r:embed="rId3" cstate="print">
+          <a:blip r:embed="rId2" cstate="print">
             <a:extLst>
               <a:ext uri="{28A0092B-C50C-407E-A947-70E740481C1C}">
                 <a14:useLocalDpi xmlns:a14="http://schemas.microsoft.com/office/drawing/2010/main" val="0"/>
@@ -7460,6 +7474,36 @@
           <a:xfrm>
             <a:off x="6096000" y="1455303"/>
             <a:ext cx="4977448" cy="4767697"/>
+          </a:xfrm>
+          <a:prstGeom prst="rect">
+            <a:avLst/>
+          </a:prstGeom>
+        </p:spPr>
+      </p:pic>
+      <p:pic>
+        <p:nvPicPr>
+          <p:cNvPr id="6" name="Obrázok 5">
+            <a:extLst>
+              <a:ext uri="{FF2B5EF4-FFF2-40B4-BE49-F238E27FC236}">
+                <a16:creationId xmlns:a16="http://schemas.microsoft.com/office/drawing/2014/main" id="{D3D8E2D6-C61D-041F-3E17-505DC2E37559}"/>
+              </a:ext>
+            </a:extLst>
+          </p:cNvPr>
+          <p:cNvPicPr>
+            <a:picLocks noChangeAspect="1"/>
+          </p:cNvPicPr>
+          <p:nvPr/>
+        </p:nvPicPr>
+        <p:blipFill>
+          <a:blip r:embed="rId3"/>
+          <a:stretch>
+            <a:fillRect/>
+          </a:stretch>
+        </p:blipFill>
+        <p:spPr>
+          <a:xfrm>
+            <a:off x="754837" y="1455303"/>
+            <a:ext cx="5172775" cy="4767697"/>
           </a:xfrm>
           <a:prstGeom prst="rect">
             <a:avLst/>

</xml_diff>

<commit_message>
nepamatam ze co, ale commit
</commit_message>
<xml_diff>
--- a/Purrifier_final.pptx
+++ b/Purrifier_final.pptx
@@ -133,6 +133,11 @@
       </a:defRPr>
     </a:lvl9pPr>
   </p:defaultTextStyle>
+  <p:extLst>
+    <p:ext uri="{EFAFB233-063F-42B5-8137-9DF3F51BA10A}">
+      <p15:sldGuideLst xmlns:p15="http://schemas.microsoft.com/office/powerpoint/2012/main"/>
+    </p:ext>
+  </p:extLst>
 </p:presentation>
 </file>
 

</xml_diff>